<commit_message>
atualiza logo para logo.png
</commit_message>
<xml_diff>
--- a/Relatorio_Taxa_Ociosidade_Relive.pptx
+++ b/Relatorio_Taxa_Ociosidade_Relive.pptx
@@ -3530,7 +3530,7 @@
       <p:grpSpPr/>
       <p:pic>
         <p:nvPicPr>
-          <p:cNvPr id="2" name="Picture 1" descr="logo-semfundo.png"/>
+          <p:cNvPr id="2" name="Picture 1" descr="logo.png"/>
           <p:cNvPicPr>
             <a:picLocks noChangeAspect="1"/>
           </p:cNvPicPr>
@@ -3699,7 +3699,7 @@
       <p:grpSpPr/>
       <p:pic>
         <p:nvPicPr>
-          <p:cNvPr id="2" name="Picture 1" descr="logo-semfundo.png"/>
+          <p:cNvPr id="2" name="Picture 1" descr="logo.png"/>
           <p:cNvPicPr>
             <a:picLocks noChangeAspect="1"/>
           </p:cNvPicPr>
@@ -4677,7 +4677,7 @@
       <p:grpSpPr/>
       <p:pic>
         <p:nvPicPr>
-          <p:cNvPr id="2" name="Picture 1" descr="logo-semfundo.png"/>
+          <p:cNvPr id="2" name="Picture 1" descr="logo.png"/>
           <p:cNvPicPr>
             <a:picLocks noChangeAspect="1"/>
           </p:cNvPicPr>
@@ -6104,7 +6104,7 @@
       <p:grpSpPr/>
       <p:pic>
         <p:nvPicPr>
-          <p:cNvPr id="2" name="Picture 1" descr="logo-semfundo.png"/>
+          <p:cNvPr id="2" name="Picture 1" descr="logo.png"/>
           <p:cNvPicPr>
             <a:picLocks noChangeAspect="1"/>
           </p:cNvPicPr>
@@ -7675,7 +7675,7 @@
       <p:grpSpPr/>
       <p:pic>
         <p:nvPicPr>
-          <p:cNvPr id="2" name="Picture 1" descr="logo-semfundo.png"/>
+          <p:cNvPr id="2" name="Picture 1" descr="logo.png"/>
           <p:cNvPicPr>
             <a:picLocks noChangeAspect="1"/>
           </p:cNvPicPr>
@@ -8404,7 +8404,7 @@
       <p:grpSpPr/>
       <p:pic>
         <p:nvPicPr>
-          <p:cNvPr id="2" name="Picture 1" descr="logo-semfundo.png"/>
+          <p:cNvPr id="2" name="Picture 1" descr="logo.png"/>
           <p:cNvPicPr>
             <a:picLocks noChangeAspect="1"/>
           </p:cNvPicPr>
@@ -9525,7 +9525,7 @@
       <p:grpSpPr/>
       <p:pic>
         <p:nvPicPr>
-          <p:cNvPr id="2" name="Picture 1" descr="logo-semfundo.png"/>
+          <p:cNvPr id="2" name="Picture 1" descr="logo.png"/>
           <p:cNvPicPr>
             <a:picLocks noChangeAspect="1"/>
           </p:cNvPicPr>
@@ -10294,7 +10294,7 @@
       <p:grpSpPr/>
       <p:pic>
         <p:nvPicPr>
-          <p:cNvPr id="2" name="Picture 1" descr="logo-semfundo.png"/>
+          <p:cNvPr id="2" name="Picture 1" descr="logo.png"/>
           <p:cNvPicPr>
             <a:picLocks noChangeAspect="1"/>
           </p:cNvPicPr>

</xml_diff>